<commit_message>
mais exemplos no notebook, paletas de cor, gráficos enganosos e acessibildade
</commit_message>
<xml_diff>
--- a/modulo3/Módulo 3.pptx
+++ b/modulo3/Módulo 3.pptx
@@ -32,21 +32,24 @@
     <p:sldId id="277" r:id="rId27"/>
     <p:sldId id="278" r:id="rId28"/>
     <p:sldId id="279" r:id="rId29"/>
+    <p:sldId id="280" r:id="rId30"/>
+    <p:sldId id="281" r:id="rId31"/>
+    <p:sldId id="282" r:id="rId32"/>
   </p:sldIdLst>
   <p:sldSz cy="5143500" cx="9144000"/>
   <p:notesSz cx="6858000" cy="9144000"/>
   <p:embeddedFontLst>
     <p:embeddedFont>
       <p:font typeface="Nunito"/>
-      <p:regular r:id="rId30"/>
-      <p:bold r:id="rId31"/>
-      <p:italic r:id="rId32"/>
-      <p:boldItalic r:id="rId33"/>
+      <p:regular r:id="rId33"/>
+      <p:bold r:id="rId34"/>
+      <p:italic r:id="rId35"/>
+      <p:boldItalic r:id="rId36"/>
     </p:embeddedFont>
     <p:embeddedFont>
       <p:font typeface="Maven Pro"/>
-      <p:regular r:id="rId34"/>
-      <p:bold r:id="rId35"/>
+      <p:regular r:id="rId37"/>
+      <p:bold r:id="rId38"/>
     </p:embeddedFont>
   </p:embeddedFontLst>
   <p:defaultTextStyle>
@@ -1930,7 +1933,7 @@
       </p:grpSpPr>
       <p:sp>
         <p:nvSpPr>
-          <p:cNvPr id="409" name="Google Shape;409;g3d3c210bb82_0_95:notes"/>
+          <p:cNvPr id="409" name="Google Shape;409;g3d8f7d7e9c1_0_1:notes"/>
           <p:cNvSpPr/>
           <p:nvPr>
             <p:ph idx="2" type="sldImg"/>
@@ -1965,7 +1968,7 @@
       </p:sp>
       <p:sp>
         <p:nvSpPr>
-          <p:cNvPr id="410" name="Google Shape;410;g3d3c210bb82_0_95:notes"/>
+          <p:cNvPr id="410" name="Google Shape;410;g3d8f7d7e9c1_0_1:notes"/>
           <p:cNvSpPr txBox="1"/>
           <p:nvPr>
             <p:ph idx="1" type="body"/>
@@ -2015,7 +2018,7 @@
   <p:cSld>
     <p:spTree>
       <p:nvGrpSpPr>
-        <p:cNvPr id="413" name="Shape 413"/>
+        <p:cNvPr id="416" name="Shape 416"/>
         <p:cNvGrpSpPr/>
         <p:nvPr/>
       </p:nvGrpSpPr>
@@ -2029,7 +2032,7 @@
       </p:grpSpPr>
       <p:sp>
         <p:nvSpPr>
-          <p:cNvPr id="414" name="Google Shape;414;g3d3c210bb82_0_100:notes"/>
+          <p:cNvPr id="417" name="Google Shape;417;g3d8f7d7e9c1_0_10:notes"/>
           <p:cNvSpPr/>
           <p:nvPr>
             <p:ph idx="2" type="sldImg"/>
@@ -2064,7 +2067,7 @@
       </p:sp>
       <p:sp>
         <p:nvSpPr>
-          <p:cNvPr id="415" name="Google Shape;415;g3d3c210bb82_0_100:notes"/>
+          <p:cNvPr id="418" name="Google Shape;418;g3d8f7d7e9c1_0_10:notes"/>
           <p:cNvSpPr txBox="1"/>
           <p:nvPr>
             <p:ph idx="1" type="body"/>
@@ -2114,7 +2117,7 @@
   <p:cSld>
     <p:spTree>
       <p:nvGrpSpPr>
-        <p:cNvPr id="419" name="Shape 419"/>
+        <p:cNvPr id="426" name="Shape 426"/>
         <p:cNvGrpSpPr/>
         <p:nvPr/>
       </p:nvGrpSpPr>
@@ -2128,7 +2131,7 @@
       </p:grpSpPr>
       <p:sp>
         <p:nvSpPr>
-          <p:cNvPr id="420" name="Google Shape;420;g3d3c210bb82_0_105:notes"/>
+          <p:cNvPr id="427" name="Google Shape;427;g3d3c210bb82_0_95:notes"/>
           <p:cNvSpPr/>
           <p:nvPr>
             <p:ph idx="2" type="sldImg"/>
@@ -2163,7 +2166,7 @@
       </p:sp>
       <p:sp>
         <p:nvSpPr>
-          <p:cNvPr id="421" name="Google Shape;421;g3d3c210bb82_0_105:notes"/>
+          <p:cNvPr id="428" name="Google Shape;428;g3d3c210bb82_0_95:notes"/>
           <p:cNvSpPr txBox="1"/>
           <p:nvPr>
             <p:ph idx="1" type="body"/>
@@ -2213,7 +2216,7 @@
   <p:cSld>
     <p:spTree>
       <p:nvGrpSpPr>
-        <p:cNvPr id="427" name="Shape 427"/>
+        <p:cNvPr id="431" name="Shape 431"/>
         <p:cNvGrpSpPr/>
         <p:nvPr/>
       </p:nvGrpSpPr>
@@ -2227,7 +2230,7 @@
       </p:grpSpPr>
       <p:sp>
         <p:nvSpPr>
-          <p:cNvPr id="428" name="Google Shape;428;g3d3c210bb82_0_117:notes"/>
+          <p:cNvPr id="432" name="Google Shape;432;g3d3c210bb82_0_100:notes"/>
           <p:cNvSpPr/>
           <p:nvPr>
             <p:ph idx="2" type="sldImg"/>
@@ -2262,7 +2265,7 @@
       </p:sp>
       <p:sp>
         <p:nvSpPr>
-          <p:cNvPr id="429" name="Google Shape;429;g3d3c210bb82_0_117:notes"/>
+          <p:cNvPr id="433" name="Google Shape;433;g3d3c210bb82_0_100:notes"/>
           <p:cNvSpPr txBox="1"/>
           <p:nvPr>
             <p:ph idx="1" type="body"/>
@@ -2312,7 +2315,7 @@
   <p:cSld>
     <p:spTree>
       <p:nvGrpSpPr>
-        <p:cNvPr id="435" name="Shape 435"/>
+        <p:cNvPr id="437" name="Shape 437"/>
         <p:cNvGrpSpPr/>
         <p:nvPr/>
       </p:nvGrpSpPr>
@@ -2326,7 +2329,7 @@
       </p:grpSpPr>
       <p:sp>
         <p:nvSpPr>
-          <p:cNvPr id="436" name="Google Shape;436;g3d3c210bb82_0_135:notes"/>
+          <p:cNvPr id="438" name="Google Shape;438;g3d3c210bb82_0_105:notes"/>
           <p:cNvSpPr/>
           <p:nvPr>
             <p:ph idx="2" type="sldImg"/>
@@ -2361,7 +2364,304 @@
       </p:sp>
       <p:sp>
         <p:nvSpPr>
-          <p:cNvPr id="437" name="Google Shape;437;g3d3c210bb82_0_135:notes"/>
+          <p:cNvPr id="439" name="Google Shape;439;g3d3c210bb82_0_105:notes"/>
+          <p:cNvSpPr txBox="1"/>
+          <p:nvPr>
+            <p:ph idx="1" type="body"/>
+          </p:nvPr>
+        </p:nvSpPr>
+        <p:spPr>
+          <a:xfrm>
+            <a:off x="685800" y="4343400"/>
+            <a:ext cx="5486400" cy="4114800"/>
+          </a:xfrm>
+          <a:prstGeom prst="rect">
+            <a:avLst/>
+          </a:prstGeom>
+        </p:spPr>
+        <p:txBody>
+          <a:bodyPr anchorCtr="0" anchor="t" bIns="91425" lIns="91425" spcFirstLastPara="1" rIns="91425" wrap="square" tIns="91425">
+            <a:noAutofit/>
+          </a:bodyPr>
+          <a:lstStyle/>
+          <a:p>
+            <a:pPr indent="0" lvl="0" marL="0" rtl="0" algn="l">
+              <a:spcBef>
+                <a:spcPts val="0"/>
+              </a:spcBef>
+              <a:spcAft>
+                <a:spcPts val="0"/>
+              </a:spcAft>
+              <a:buNone/>
+            </a:pPr>
+            <a:r>
+              <a:t/>
+            </a:r>
+            <a:endParaRPr/>
+          </a:p>
+        </p:txBody>
+      </p:sp>
+    </p:spTree>
+  </p:cSld>
+  <p:clrMapOvr>
+    <a:masterClrMapping/>
+  </p:clrMapOvr>
+</p:notes>
+</file>
+
+<file path=ppt/notesSlides/notesSlide25.xml><?xml version="1.0" encoding="utf-8"?>
+<p:notes xmlns:a="http://schemas.openxmlformats.org/drawingml/2006/main" xmlns:r="http://schemas.openxmlformats.org/officeDocument/2006/relationships" xmlns:mc="http://schemas.openxmlformats.org/markup-compatibility/2006" xmlns:mv="urn:schemas-microsoft-com:mac:vml" xmlns:p="http://schemas.openxmlformats.org/presentationml/2006/main" xmlns:c="http://schemas.openxmlformats.org/drawingml/2006/chart" xmlns:dgm="http://schemas.openxmlformats.org/drawingml/2006/diagram" xmlns:o="urn:schemas-microsoft-com:office:office" xmlns:v="urn:schemas-microsoft-com:vml" xmlns:pvml="urn:schemas-microsoft-com:office:powerpoint" xmlns:com="http://schemas.openxmlformats.org/drawingml/2006/compatibility" xmlns:p14="http://schemas.microsoft.com/office/powerpoint/2010/main" xmlns:p15="http://schemas.microsoft.com/office/powerpoint/2012/main" xmlns:ahyp="http://schemas.microsoft.com/office/drawing/2018/hyperlinkcolor" showMasterPhAnim="0" showMasterSp="0">
+  <p:cSld>
+    <p:spTree>
+      <p:nvGrpSpPr>
+        <p:cNvPr id="445" name="Shape 445"/>
+        <p:cNvGrpSpPr/>
+        <p:nvPr/>
+      </p:nvGrpSpPr>
+      <p:grpSpPr>
+        <a:xfrm>
+          <a:off x="0" y="0"/>
+          <a:ext cx="0" cy="0"/>
+          <a:chOff x="0" y="0"/>
+          <a:chExt cx="0" cy="0"/>
+        </a:xfrm>
+      </p:grpSpPr>
+      <p:sp>
+        <p:nvSpPr>
+          <p:cNvPr id="446" name="Google Shape;446;g3d8f7d7e9c1_0_20:notes"/>
+          <p:cNvSpPr/>
+          <p:nvPr>
+            <p:ph idx="2" type="sldImg"/>
+          </p:nvPr>
+        </p:nvSpPr>
+        <p:spPr>
+          <a:xfrm>
+            <a:off x="381300" y="685800"/>
+            <a:ext cx="6096000" cy="3429000"/>
+          </a:xfrm>
+          <a:custGeom>
+            <a:rect b="b" l="l" r="r" t="t"/>
+            <a:pathLst>
+              <a:path extrusionOk="0" h="120000" w="120000">
+                <a:moveTo>
+                  <a:pt x="0" y="0"/>
+                </a:moveTo>
+                <a:lnTo>
+                  <a:pt x="120000" y="0"/>
+                </a:lnTo>
+                <a:lnTo>
+                  <a:pt x="120000" y="120000"/>
+                </a:lnTo>
+                <a:lnTo>
+                  <a:pt x="0" y="120000"/>
+                </a:lnTo>
+                <a:close/>
+              </a:path>
+            </a:pathLst>
+          </a:custGeom>
+        </p:spPr>
+      </p:sp>
+      <p:sp>
+        <p:nvSpPr>
+          <p:cNvPr id="447" name="Google Shape;447;g3d8f7d7e9c1_0_20:notes"/>
+          <p:cNvSpPr txBox="1"/>
+          <p:nvPr>
+            <p:ph idx="1" type="body"/>
+          </p:nvPr>
+        </p:nvSpPr>
+        <p:spPr>
+          <a:xfrm>
+            <a:off x="685800" y="4343400"/>
+            <a:ext cx="5486400" cy="4114800"/>
+          </a:xfrm>
+          <a:prstGeom prst="rect">
+            <a:avLst/>
+          </a:prstGeom>
+        </p:spPr>
+        <p:txBody>
+          <a:bodyPr anchorCtr="0" anchor="t" bIns="91425" lIns="91425" spcFirstLastPara="1" rIns="91425" wrap="square" tIns="91425">
+            <a:noAutofit/>
+          </a:bodyPr>
+          <a:lstStyle/>
+          <a:p>
+            <a:pPr indent="0" lvl="0" marL="0" rtl="0" algn="l">
+              <a:spcBef>
+                <a:spcPts val="0"/>
+              </a:spcBef>
+              <a:spcAft>
+                <a:spcPts val="0"/>
+              </a:spcAft>
+              <a:buNone/>
+            </a:pPr>
+            <a:r>
+              <a:t/>
+            </a:r>
+            <a:endParaRPr/>
+          </a:p>
+        </p:txBody>
+      </p:sp>
+    </p:spTree>
+  </p:cSld>
+  <p:clrMapOvr>
+    <a:masterClrMapping/>
+  </p:clrMapOvr>
+</p:notes>
+</file>
+
+<file path=ppt/notesSlides/notesSlide26.xml><?xml version="1.0" encoding="utf-8"?>
+<p:notes xmlns:a="http://schemas.openxmlformats.org/drawingml/2006/main" xmlns:r="http://schemas.openxmlformats.org/officeDocument/2006/relationships" xmlns:mc="http://schemas.openxmlformats.org/markup-compatibility/2006" xmlns:mv="urn:schemas-microsoft-com:mac:vml" xmlns:p="http://schemas.openxmlformats.org/presentationml/2006/main" xmlns:c="http://schemas.openxmlformats.org/drawingml/2006/chart" xmlns:dgm="http://schemas.openxmlformats.org/drawingml/2006/diagram" xmlns:o="urn:schemas-microsoft-com:office:office" xmlns:v="urn:schemas-microsoft-com:vml" xmlns:pvml="urn:schemas-microsoft-com:office:powerpoint" xmlns:com="http://schemas.openxmlformats.org/drawingml/2006/compatibility" xmlns:p14="http://schemas.microsoft.com/office/powerpoint/2010/main" xmlns:p15="http://schemas.microsoft.com/office/powerpoint/2012/main" xmlns:ahyp="http://schemas.microsoft.com/office/drawing/2018/hyperlinkcolor" showMasterPhAnim="0" showMasterSp="0">
+  <p:cSld>
+    <p:spTree>
+      <p:nvGrpSpPr>
+        <p:cNvPr id="454" name="Shape 454"/>
+        <p:cNvGrpSpPr/>
+        <p:nvPr/>
+      </p:nvGrpSpPr>
+      <p:grpSpPr>
+        <a:xfrm>
+          <a:off x="0" y="0"/>
+          <a:ext cx="0" cy="0"/>
+          <a:chOff x="0" y="0"/>
+          <a:chExt cx="0" cy="0"/>
+        </a:xfrm>
+      </p:grpSpPr>
+      <p:sp>
+        <p:nvSpPr>
+          <p:cNvPr id="455" name="Google Shape;455;g3d3c210bb82_0_117:notes"/>
+          <p:cNvSpPr/>
+          <p:nvPr>
+            <p:ph idx="2" type="sldImg"/>
+          </p:nvPr>
+        </p:nvSpPr>
+        <p:spPr>
+          <a:xfrm>
+            <a:off x="381300" y="685800"/>
+            <a:ext cx="6096000" cy="3429000"/>
+          </a:xfrm>
+          <a:custGeom>
+            <a:rect b="b" l="l" r="r" t="t"/>
+            <a:pathLst>
+              <a:path extrusionOk="0" h="120000" w="120000">
+                <a:moveTo>
+                  <a:pt x="0" y="0"/>
+                </a:moveTo>
+                <a:lnTo>
+                  <a:pt x="120000" y="0"/>
+                </a:lnTo>
+                <a:lnTo>
+                  <a:pt x="120000" y="120000"/>
+                </a:lnTo>
+                <a:lnTo>
+                  <a:pt x="0" y="120000"/>
+                </a:lnTo>
+                <a:close/>
+              </a:path>
+            </a:pathLst>
+          </a:custGeom>
+        </p:spPr>
+      </p:sp>
+      <p:sp>
+        <p:nvSpPr>
+          <p:cNvPr id="456" name="Google Shape;456;g3d3c210bb82_0_117:notes"/>
+          <p:cNvSpPr txBox="1"/>
+          <p:nvPr>
+            <p:ph idx="1" type="body"/>
+          </p:nvPr>
+        </p:nvSpPr>
+        <p:spPr>
+          <a:xfrm>
+            <a:off x="685800" y="4343400"/>
+            <a:ext cx="5486400" cy="4114800"/>
+          </a:xfrm>
+          <a:prstGeom prst="rect">
+            <a:avLst/>
+          </a:prstGeom>
+        </p:spPr>
+        <p:txBody>
+          <a:bodyPr anchorCtr="0" anchor="t" bIns="91425" lIns="91425" spcFirstLastPara="1" rIns="91425" wrap="square" tIns="91425">
+            <a:noAutofit/>
+          </a:bodyPr>
+          <a:lstStyle/>
+          <a:p>
+            <a:pPr indent="0" lvl="0" marL="0" rtl="0" algn="l">
+              <a:spcBef>
+                <a:spcPts val="0"/>
+              </a:spcBef>
+              <a:spcAft>
+                <a:spcPts val="0"/>
+              </a:spcAft>
+              <a:buNone/>
+            </a:pPr>
+            <a:r>
+              <a:t/>
+            </a:r>
+            <a:endParaRPr/>
+          </a:p>
+        </p:txBody>
+      </p:sp>
+    </p:spTree>
+  </p:cSld>
+  <p:clrMapOvr>
+    <a:masterClrMapping/>
+  </p:clrMapOvr>
+</p:notes>
+</file>
+
+<file path=ppt/notesSlides/notesSlide27.xml><?xml version="1.0" encoding="utf-8"?>
+<p:notes xmlns:a="http://schemas.openxmlformats.org/drawingml/2006/main" xmlns:r="http://schemas.openxmlformats.org/officeDocument/2006/relationships" xmlns:mc="http://schemas.openxmlformats.org/markup-compatibility/2006" xmlns:mv="urn:schemas-microsoft-com:mac:vml" xmlns:p="http://schemas.openxmlformats.org/presentationml/2006/main" xmlns:c="http://schemas.openxmlformats.org/drawingml/2006/chart" xmlns:dgm="http://schemas.openxmlformats.org/drawingml/2006/diagram" xmlns:o="urn:schemas-microsoft-com:office:office" xmlns:v="urn:schemas-microsoft-com:vml" xmlns:pvml="urn:schemas-microsoft-com:office:powerpoint" xmlns:com="http://schemas.openxmlformats.org/drawingml/2006/compatibility" xmlns:p14="http://schemas.microsoft.com/office/powerpoint/2010/main" xmlns:p15="http://schemas.microsoft.com/office/powerpoint/2012/main" xmlns:ahyp="http://schemas.microsoft.com/office/drawing/2018/hyperlinkcolor" showMasterPhAnim="0" showMasterSp="0">
+  <p:cSld>
+    <p:spTree>
+      <p:nvGrpSpPr>
+        <p:cNvPr id="462" name="Shape 462"/>
+        <p:cNvGrpSpPr/>
+        <p:nvPr/>
+      </p:nvGrpSpPr>
+      <p:grpSpPr>
+        <a:xfrm>
+          <a:off x="0" y="0"/>
+          <a:ext cx="0" cy="0"/>
+          <a:chOff x="0" y="0"/>
+          <a:chExt cx="0" cy="0"/>
+        </a:xfrm>
+      </p:grpSpPr>
+      <p:sp>
+        <p:nvSpPr>
+          <p:cNvPr id="463" name="Google Shape;463;g3d3c210bb82_0_135:notes"/>
+          <p:cNvSpPr/>
+          <p:nvPr>
+            <p:ph idx="2" type="sldImg"/>
+          </p:nvPr>
+        </p:nvSpPr>
+        <p:spPr>
+          <a:xfrm>
+            <a:off x="381300" y="685800"/>
+            <a:ext cx="6096000" cy="3429000"/>
+          </a:xfrm>
+          <a:custGeom>
+            <a:rect b="b" l="l" r="r" t="t"/>
+            <a:pathLst>
+              <a:path extrusionOk="0" h="120000" w="120000">
+                <a:moveTo>
+                  <a:pt x="0" y="0"/>
+                </a:moveTo>
+                <a:lnTo>
+                  <a:pt x="120000" y="0"/>
+                </a:lnTo>
+                <a:lnTo>
+                  <a:pt x="120000" y="120000"/>
+                </a:lnTo>
+                <a:lnTo>
+                  <a:pt x="0" y="120000"/>
+                </a:lnTo>
+                <a:close/>
+              </a:path>
+            </a:pathLst>
+          </a:custGeom>
+        </p:spPr>
+      </p:sp>
+      <p:sp>
+        <p:nvSpPr>
+          <p:cNvPr id="464" name="Google Shape;464;g3d3c210bb82_0_135:notes"/>
           <p:cNvSpPr txBox="1"/>
           <p:nvPr>
             <p:ph idx="1" type="body"/>
@@ -19560,6 +19860,619 @@
         </p:nvSpPr>
         <p:spPr>
           <a:xfrm>
+            <a:off x="1303800" y="598575"/>
+            <a:ext cx="3923700" cy="1590000"/>
+          </a:xfrm>
+          <a:prstGeom prst="rect">
+            <a:avLst/>
+          </a:prstGeom>
+        </p:spPr>
+        <p:txBody>
+          <a:bodyPr anchorCtr="0" anchor="t" bIns="91425" lIns="91425" spcFirstLastPara="1" rIns="91425" wrap="square" tIns="91425">
+            <a:normAutofit/>
+          </a:bodyPr>
+          <a:lstStyle/>
+          <a:p>
+            <a:pPr indent="0" lvl="0" marL="0" rtl="0" algn="l">
+              <a:spcBef>
+                <a:spcPts val="0"/>
+              </a:spcBef>
+              <a:spcAft>
+                <a:spcPts val="0"/>
+              </a:spcAft>
+              <a:buNone/>
+            </a:pPr>
+            <a:r>
+              <a:rPr lang="en"/>
+              <a:t>Paletas sequenciais</a:t>
+            </a:r>
+            <a:endParaRPr/>
+          </a:p>
+        </p:txBody>
+      </p:sp>
+      <p:sp>
+        <p:nvSpPr>
+          <p:cNvPr id="413" name="Google Shape;413;p32"/>
+          <p:cNvSpPr txBox="1"/>
+          <p:nvPr>
+            <p:ph idx="1" type="body"/>
+          </p:nvPr>
+        </p:nvSpPr>
+        <p:spPr>
+          <a:xfrm>
+            <a:off x="1303800" y="1679500"/>
+            <a:ext cx="3312000" cy="2852100"/>
+          </a:xfrm>
+          <a:prstGeom prst="rect">
+            <a:avLst/>
+          </a:prstGeom>
+        </p:spPr>
+        <p:txBody>
+          <a:bodyPr anchorCtr="0" anchor="t" bIns="91425" lIns="91425" spcFirstLastPara="1" rIns="91425" wrap="square" tIns="91425">
+            <a:normAutofit/>
+          </a:bodyPr>
+          <a:lstStyle/>
+          <a:p>
+            <a:pPr indent="0" lvl="0" marL="0" rtl="0" algn="l">
+              <a:spcBef>
+                <a:spcPts val="0"/>
+              </a:spcBef>
+              <a:spcAft>
+                <a:spcPts val="0"/>
+              </a:spcAft>
+              <a:buNone/>
+            </a:pPr>
+            <a:r>
+              <a:rPr lang="en" sz="1100">
+                <a:solidFill>
+                  <a:srgbClr val="000000"/>
+                </a:solidFill>
+              </a:rPr>
+              <a:t>São utilizadas para representar dados numéricos que possuem uma </a:t>
+            </a:r>
+            <a:r>
+              <a:rPr b="1" lang="en" sz="1100">
+                <a:solidFill>
+                  <a:srgbClr val="000000"/>
+                </a:solidFill>
+              </a:rPr>
+              <a:t>ordem lógica ou gradação de intensidade</a:t>
+            </a:r>
+            <a:r>
+              <a:rPr lang="en" sz="1100">
+                <a:solidFill>
+                  <a:srgbClr val="000000"/>
+                </a:solidFill>
+              </a:rPr>
+              <a:t>, como volume de vendas, temperatura ou densidade populacional.</a:t>
+            </a:r>
+            <a:endParaRPr sz="1100">
+              <a:solidFill>
+                <a:srgbClr val="000000"/>
+              </a:solidFill>
+            </a:endParaRPr>
+          </a:p>
+          <a:p>
+            <a:pPr indent="0" lvl="0" marL="0" rtl="0" algn="l">
+              <a:spcBef>
+                <a:spcPts val="1200"/>
+              </a:spcBef>
+              <a:spcAft>
+                <a:spcPts val="0"/>
+              </a:spcAft>
+              <a:buNone/>
+            </a:pPr>
+            <a:r>
+              <a:rPr lang="en" sz="1100">
+                <a:solidFill>
+                  <a:srgbClr val="000000"/>
+                </a:solidFill>
+              </a:rPr>
+              <a:t>Geralmente variam de uma cor clara e suave (para valores baixos) até uma cor escura e saturada (para valores altos), permitindo que o público identifique instantaneamente onde estão as maiores concentrações de dados.</a:t>
+            </a:r>
+            <a:endParaRPr sz="1100">
+              <a:solidFill>
+                <a:srgbClr val="000000"/>
+              </a:solidFill>
+            </a:endParaRPr>
+          </a:p>
+          <a:p>
+            <a:pPr indent="0" lvl="0" marL="0" rtl="0" algn="l">
+              <a:spcBef>
+                <a:spcPts val="1200"/>
+              </a:spcBef>
+              <a:spcAft>
+                <a:spcPts val="1200"/>
+              </a:spcAft>
+              <a:buNone/>
+            </a:pPr>
+            <a:r>
+              <a:rPr lang="en" sz="1100">
+                <a:solidFill>
+                  <a:srgbClr val="000000"/>
+                </a:solidFill>
+              </a:rPr>
+              <a:t>No Seaborn e Matplotlib, exemplos populares incluem as paletas </a:t>
+            </a:r>
+            <a:r>
+              <a:rPr lang="en" sz="1100">
+                <a:solidFill>
+                  <a:srgbClr val="188038"/>
+                </a:solidFill>
+              </a:rPr>
+              <a:t>Blues</a:t>
+            </a:r>
+            <a:r>
+              <a:rPr lang="en" sz="1100">
+                <a:solidFill>
+                  <a:srgbClr val="000000"/>
+                </a:solidFill>
+              </a:rPr>
+              <a:t>, </a:t>
+            </a:r>
+            <a:r>
+              <a:rPr lang="en" sz="1100">
+                <a:solidFill>
+                  <a:srgbClr val="188038"/>
+                </a:solidFill>
+              </a:rPr>
+              <a:t>Reds</a:t>
+            </a:r>
+            <a:r>
+              <a:rPr lang="en" sz="1100">
+                <a:solidFill>
+                  <a:srgbClr val="000000"/>
+                </a:solidFill>
+              </a:rPr>
+              <a:t> ou a perceptualmente uniforme </a:t>
+            </a:r>
+            <a:r>
+              <a:rPr lang="en" sz="1100">
+                <a:solidFill>
+                  <a:srgbClr val="188038"/>
+                </a:solidFill>
+              </a:rPr>
+              <a:t>viridis</a:t>
+            </a:r>
+            <a:r>
+              <a:rPr lang="en" sz="1100">
+                <a:solidFill>
+                  <a:srgbClr val="000000"/>
+                </a:solidFill>
+              </a:rPr>
+              <a:t>.</a:t>
+            </a:r>
+            <a:endParaRPr/>
+          </a:p>
+        </p:txBody>
+      </p:sp>
+      <p:sp>
+        <p:nvSpPr>
+          <p:cNvPr id="414" name="Google Shape;414;p32"/>
+          <p:cNvSpPr txBox="1"/>
+          <p:nvPr/>
+        </p:nvSpPr>
+        <p:spPr>
+          <a:xfrm>
+            <a:off x="4835600" y="3934600"/>
+            <a:ext cx="3744000" cy="336000"/>
+          </a:xfrm>
+          <a:prstGeom prst="rect">
+            <a:avLst/>
+          </a:prstGeom>
+          <a:noFill/>
+          <a:ln>
+            <a:noFill/>
+          </a:ln>
+        </p:spPr>
+        <p:txBody>
+          <a:bodyPr anchorCtr="0" anchor="t" bIns="91425" lIns="91425" spcFirstLastPara="1" rIns="91425" wrap="square" tIns="91425">
+            <a:noAutofit/>
+          </a:bodyPr>
+          <a:lstStyle/>
+          <a:p>
+            <a:pPr indent="0" lvl="0" marL="0" rtl="0" algn="ctr">
+              <a:spcBef>
+                <a:spcPts val="0"/>
+              </a:spcBef>
+              <a:spcAft>
+                <a:spcPts val="0"/>
+              </a:spcAft>
+              <a:buNone/>
+            </a:pPr>
+            <a:r>
+              <a:rPr lang="en" sz="1300">
+                <a:solidFill>
+                  <a:schemeClr val="dk2"/>
+                </a:solidFill>
+                <a:latin typeface="Nunito"/>
+                <a:ea typeface="Nunito"/>
+                <a:cs typeface="Nunito"/>
+                <a:sym typeface="Nunito"/>
+              </a:rPr>
+              <a:t>Fonte: documentação do Matplotlib</a:t>
+            </a:r>
+            <a:endParaRPr sz="1300">
+              <a:solidFill>
+                <a:schemeClr val="dk2"/>
+              </a:solidFill>
+              <a:latin typeface="Nunito"/>
+              <a:ea typeface="Nunito"/>
+              <a:cs typeface="Nunito"/>
+              <a:sym typeface="Nunito"/>
+            </a:endParaRPr>
+          </a:p>
+        </p:txBody>
+      </p:sp>
+      <p:pic>
+        <p:nvPicPr>
+          <p:cNvPr id="415" name="Google Shape;415;p32"/>
+          <p:cNvPicPr preferRelativeResize="0"/>
+          <p:nvPr/>
+        </p:nvPicPr>
+        <p:blipFill rotWithShape="1">
+          <a:blip r:embed="rId3">
+            <a:alphaModFix/>
+          </a:blip>
+          <a:srcRect b="0" l="9420" r="0" t="0"/>
+          <a:stretch/>
+        </p:blipFill>
+        <p:spPr>
+          <a:xfrm>
+            <a:off x="4937350" y="2106375"/>
+            <a:ext cx="3824174" cy="1108300"/>
+          </a:xfrm>
+          <a:prstGeom prst="rect">
+            <a:avLst/>
+          </a:prstGeom>
+          <a:noFill/>
+          <a:ln>
+            <a:noFill/>
+          </a:ln>
+        </p:spPr>
+      </p:pic>
+    </p:spTree>
+  </p:cSld>
+  <p:clrMapOvr>
+    <a:masterClrMapping/>
+  </p:clrMapOvr>
+</p:sld>
+</file>
+
+<file path=ppt/slides/slide21.xml><?xml version="1.0" encoding="utf-8"?>
+<p:sld xmlns:a="http://schemas.openxmlformats.org/drawingml/2006/main" xmlns:r="http://schemas.openxmlformats.org/officeDocument/2006/relationships" xmlns:mc="http://schemas.openxmlformats.org/markup-compatibility/2006" xmlns:mv="urn:schemas-microsoft-com:mac:vml" xmlns:p="http://schemas.openxmlformats.org/presentationml/2006/main" xmlns:c="http://schemas.openxmlformats.org/drawingml/2006/chart" xmlns:dgm="http://schemas.openxmlformats.org/drawingml/2006/diagram" xmlns:o="urn:schemas-microsoft-com:office:office" xmlns:v="urn:schemas-microsoft-com:vml" xmlns:pvml="urn:schemas-microsoft-com:office:powerpoint" xmlns:com="http://schemas.openxmlformats.org/drawingml/2006/compatibility" xmlns:p14="http://schemas.microsoft.com/office/powerpoint/2010/main" xmlns:p15="http://schemas.microsoft.com/office/powerpoint/2012/main" xmlns:ahyp="http://schemas.microsoft.com/office/drawing/2018/hyperlinkcolor">
+  <p:cSld>
+    <p:spTree>
+      <p:nvGrpSpPr>
+        <p:cNvPr id="419" name="Shape 419"/>
+        <p:cNvGrpSpPr/>
+        <p:nvPr/>
+      </p:nvGrpSpPr>
+      <p:grpSpPr>
+        <a:xfrm>
+          <a:off x="0" y="0"/>
+          <a:ext cx="0" cy="0"/>
+          <a:chOff x="0" y="0"/>
+          <a:chExt cx="0" cy="0"/>
+        </a:xfrm>
+      </p:grpSpPr>
+      <p:sp>
+        <p:nvSpPr>
+          <p:cNvPr id="420" name="Google Shape;420;p33"/>
+          <p:cNvSpPr txBox="1"/>
+          <p:nvPr>
+            <p:ph type="title"/>
+          </p:nvPr>
+        </p:nvSpPr>
+        <p:spPr>
+          <a:xfrm>
+            <a:off x="1303800" y="598575"/>
+            <a:ext cx="3312000" cy="1590000"/>
+          </a:xfrm>
+          <a:prstGeom prst="rect">
+            <a:avLst/>
+          </a:prstGeom>
+        </p:spPr>
+        <p:txBody>
+          <a:bodyPr anchorCtr="0" anchor="t" bIns="91425" lIns="91425" spcFirstLastPara="1" rIns="91425" wrap="square" tIns="91425">
+            <a:normAutofit/>
+          </a:bodyPr>
+          <a:lstStyle/>
+          <a:p>
+            <a:pPr indent="0" lvl="0" marL="0" rtl="0" algn="l">
+              <a:spcBef>
+                <a:spcPts val="0"/>
+              </a:spcBef>
+              <a:spcAft>
+                <a:spcPts val="0"/>
+              </a:spcAft>
+              <a:buNone/>
+            </a:pPr>
+            <a:r>
+              <a:rPr lang="en"/>
+              <a:t>Acessibilidade na visualizaç</a:t>
+            </a:r>
+            <a:r>
+              <a:rPr lang="en"/>
+              <a:t>ão</a:t>
+            </a:r>
+            <a:endParaRPr/>
+          </a:p>
+        </p:txBody>
+      </p:sp>
+      <p:sp>
+        <p:nvSpPr>
+          <p:cNvPr id="421" name="Google Shape;421;p33"/>
+          <p:cNvSpPr txBox="1"/>
+          <p:nvPr>
+            <p:ph idx="1" type="body"/>
+          </p:nvPr>
+        </p:nvSpPr>
+        <p:spPr>
+          <a:xfrm>
+            <a:off x="1303800" y="2309675"/>
+            <a:ext cx="3312000" cy="2221800"/>
+          </a:xfrm>
+          <a:prstGeom prst="rect">
+            <a:avLst/>
+          </a:prstGeom>
+        </p:spPr>
+        <p:txBody>
+          <a:bodyPr anchorCtr="0" anchor="t" bIns="91425" lIns="91425" spcFirstLastPara="1" rIns="91425" wrap="square" tIns="91425">
+            <a:normAutofit/>
+          </a:bodyPr>
+          <a:lstStyle/>
+          <a:p>
+            <a:pPr indent="0" lvl="0" marL="0" rtl="0" algn="l">
+              <a:spcBef>
+                <a:spcPts val="0"/>
+              </a:spcBef>
+              <a:spcAft>
+                <a:spcPts val="0"/>
+              </a:spcAft>
+              <a:buNone/>
+            </a:pPr>
+            <a:r>
+              <a:rPr lang="en"/>
+              <a:t>Alguns tipos de daltonismo podem dificultar a visualizaç</a:t>
+            </a:r>
+            <a:r>
+              <a:rPr lang="en"/>
+              <a:t>ão e a interpretação dos gráficos, dependendo das cores aplicadas (ex: verde e vermelho).</a:t>
+            </a:r>
+            <a:endParaRPr/>
+          </a:p>
+          <a:p>
+            <a:pPr indent="0" lvl="0" marL="0" rtl="0" algn="l">
+              <a:spcBef>
+                <a:spcPts val="1200"/>
+              </a:spcBef>
+              <a:spcAft>
+                <a:spcPts val="1200"/>
+              </a:spcAft>
+              <a:buNone/>
+            </a:pPr>
+            <a:r>
+              <a:rPr lang="en"/>
+              <a:t>Para evitar esse problema, priorize paletas </a:t>
+            </a:r>
+            <a:r>
+              <a:rPr b="1" lang="en"/>
+              <a:t>perceptualmente uniformes</a:t>
+            </a:r>
+            <a:r>
+              <a:rPr lang="en"/>
+              <a:t>.</a:t>
+            </a:r>
+            <a:endParaRPr/>
+          </a:p>
+        </p:txBody>
+      </p:sp>
+      <p:pic>
+        <p:nvPicPr>
+          <p:cNvPr id="422" name="Google Shape;422;p33"/>
+          <p:cNvPicPr preferRelativeResize="0"/>
+          <p:nvPr/>
+        </p:nvPicPr>
+        <p:blipFill rotWithShape="1">
+          <a:blip r:embed="rId3">
+            <a:alphaModFix/>
+          </a:blip>
+          <a:srcRect b="0" l="0" r="49385" t="0"/>
+          <a:stretch/>
+        </p:blipFill>
+        <p:spPr>
+          <a:xfrm>
+            <a:off x="5606300" y="629787"/>
+            <a:ext cx="2459949" cy="1973813"/>
+          </a:xfrm>
+          <a:prstGeom prst="rect">
+            <a:avLst/>
+          </a:prstGeom>
+          <a:noFill/>
+          <a:ln>
+            <a:noFill/>
+          </a:ln>
+        </p:spPr>
+      </p:pic>
+      <p:pic>
+        <p:nvPicPr>
+          <p:cNvPr id="423" name="Google Shape;423;p33"/>
+          <p:cNvPicPr preferRelativeResize="0"/>
+          <p:nvPr/>
+        </p:nvPicPr>
+        <p:blipFill rotWithShape="1">
+          <a:blip r:embed="rId3">
+            <a:alphaModFix/>
+          </a:blip>
+          <a:srcRect b="0" l="50308" r="0" t="0"/>
+          <a:stretch/>
+        </p:blipFill>
+        <p:spPr>
+          <a:xfrm>
+            <a:off x="5606300" y="3021600"/>
+            <a:ext cx="2459949" cy="2010450"/>
+          </a:xfrm>
+          <a:prstGeom prst="rect">
+            <a:avLst/>
+          </a:prstGeom>
+          <a:noFill/>
+          <a:ln>
+            <a:noFill/>
+          </a:ln>
+        </p:spPr>
+      </p:pic>
+      <p:sp>
+        <p:nvSpPr>
+          <p:cNvPr id="424" name="Google Shape;424;p33"/>
+          <p:cNvSpPr txBox="1"/>
+          <p:nvPr/>
+        </p:nvSpPr>
+        <p:spPr>
+          <a:xfrm>
+            <a:off x="5773325" y="328900"/>
+            <a:ext cx="1896600" cy="300900"/>
+          </a:xfrm>
+          <a:prstGeom prst="rect">
+            <a:avLst/>
+          </a:prstGeom>
+          <a:noFill/>
+          <a:ln>
+            <a:noFill/>
+          </a:ln>
+        </p:spPr>
+        <p:txBody>
+          <a:bodyPr anchorCtr="0" anchor="t" bIns="91425" lIns="91425" spcFirstLastPara="1" rIns="91425" wrap="square" tIns="91425">
+            <a:noAutofit/>
+          </a:bodyPr>
+          <a:lstStyle/>
+          <a:p>
+            <a:pPr indent="0" lvl="0" marL="0" rtl="0" algn="ctr">
+              <a:spcBef>
+                <a:spcPts val="0"/>
+              </a:spcBef>
+              <a:spcAft>
+                <a:spcPts val="0"/>
+              </a:spcAft>
+              <a:buNone/>
+            </a:pPr>
+            <a:r>
+              <a:rPr b="1" lang="en" sz="1300">
+                <a:solidFill>
+                  <a:schemeClr val="dk2"/>
+                </a:solidFill>
+                <a:latin typeface="Nunito"/>
+                <a:ea typeface="Nunito"/>
+                <a:cs typeface="Nunito"/>
+                <a:sym typeface="Nunito"/>
+              </a:rPr>
+              <a:t>Paleta não-acessível</a:t>
+            </a:r>
+            <a:endParaRPr b="1" sz="1300">
+              <a:solidFill>
+                <a:schemeClr val="dk2"/>
+              </a:solidFill>
+              <a:latin typeface="Nunito"/>
+              <a:ea typeface="Nunito"/>
+              <a:cs typeface="Nunito"/>
+              <a:sym typeface="Nunito"/>
+            </a:endParaRPr>
+          </a:p>
+        </p:txBody>
+      </p:sp>
+      <p:sp>
+        <p:nvSpPr>
+          <p:cNvPr id="425" name="Google Shape;425;p33"/>
+          <p:cNvSpPr txBox="1"/>
+          <p:nvPr/>
+        </p:nvSpPr>
+        <p:spPr>
+          <a:xfrm>
+            <a:off x="5206650" y="2720700"/>
+            <a:ext cx="3030000" cy="300900"/>
+          </a:xfrm>
+          <a:prstGeom prst="rect">
+            <a:avLst/>
+          </a:prstGeom>
+          <a:noFill/>
+          <a:ln>
+            <a:noFill/>
+          </a:ln>
+        </p:spPr>
+        <p:txBody>
+          <a:bodyPr anchorCtr="0" anchor="t" bIns="91425" lIns="91425" spcFirstLastPara="1" rIns="91425" wrap="square" tIns="91425">
+            <a:noAutofit/>
+          </a:bodyPr>
+          <a:lstStyle/>
+          <a:p>
+            <a:pPr indent="0" lvl="0" marL="0" rtl="0" algn="ctr">
+              <a:spcBef>
+                <a:spcPts val="0"/>
+              </a:spcBef>
+              <a:spcAft>
+                <a:spcPts val="0"/>
+              </a:spcAft>
+              <a:buNone/>
+            </a:pPr>
+            <a:r>
+              <a:rPr b="1" lang="en" sz="1300">
+                <a:solidFill>
+                  <a:schemeClr val="dk2"/>
+                </a:solidFill>
+                <a:latin typeface="Nunito"/>
+                <a:ea typeface="Nunito"/>
+                <a:cs typeface="Nunito"/>
+                <a:sym typeface="Nunito"/>
+              </a:rPr>
+              <a:t>Paleta perceptualmente uniforme</a:t>
+            </a:r>
+            <a:endParaRPr b="1" sz="1300">
+              <a:solidFill>
+                <a:schemeClr val="dk2"/>
+              </a:solidFill>
+              <a:latin typeface="Nunito"/>
+              <a:ea typeface="Nunito"/>
+              <a:cs typeface="Nunito"/>
+              <a:sym typeface="Nunito"/>
+            </a:endParaRPr>
+          </a:p>
+        </p:txBody>
+      </p:sp>
+    </p:spTree>
+  </p:cSld>
+  <p:clrMapOvr>
+    <a:masterClrMapping/>
+  </p:clrMapOvr>
+</p:sld>
+</file>
+
+<file path=ppt/slides/slide22.xml><?xml version="1.0" encoding="utf-8"?>
+<p:sld xmlns:a="http://schemas.openxmlformats.org/drawingml/2006/main" xmlns:r="http://schemas.openxmlformats.org/officeDocument/2006/relationships" xmlns:mc="http://schemas.openxmlformats.org/markup-compatibility/2006" xmlns:mv="urn:schemas-microsoft-com:mac:vml" xmlns:p="http://schemas.openxmlformats.org/presentationml/2006/main" xmlns:c="http://schemas.openxmlformats.org/drawingml/2006/chart" xmlns:dgm="http://schemas.openxmlformats.org/drawingml/2006/diagram" xmlns:o="urn:schemas-microsoft-com:office:office" xmlns:v="urn:schemas-microsoft-com:vml" xmlns:pvml="urn:schemas-microsoft-com:office:powerpoint" xmlns:com="http://schemas.openxmlformats.org/drawingml/2006/compatibility" xmlns:p14="http://schemas.microsoft.com/office/powerpoint/2010/main" xmlns:p15="http://schemas.microsoft.com/office/powerpoint/2012/main" xmlns:ahyp="http://schemas.microsoft.com/office/drawing/2018/hyperlinkcolor">
+  <p:cSld>
+    <p:spTree>
+      <p:nvGrpSpPr>
+        <p:cNvPr id="429" name="Shape 429"/>
+        <p:cNvGrpSpPr/>
+        <p:nvPr/>
+      </p:nvGrpSpPr>
+      <p:grpSpPr>
+        <a:xfrm>
+          <a:off x="0" y="0"/>
+          <a:ext cx="0" cy="0"/>
+          <a:chOff x="0" y="0"/>
+          <a:chExt cx="0" cy="0"/>
+        </a:xfrm>
+      </p:grpSpPr>
+      <p:sp>
+        <p:nvSpPr>
+          <p:cNvPr id="430" name="Google Shape;430;p34"/>
+          <p:cNvSpPr txBox="1"/>
+          <p:nvPr>
+            <p:ph type="title"/>
+          </p:nvPr>
+        </p:nvSpPr>
+        <p:spPr>
+          <a:xfrm>
             <a:off x="824000" y="1613825"/>
             <a:ext cx="5857800" cy="1872900"/>
           </a:xfrm>
@@ -19598,12 +20511,12 @@
 </p:sld>
 </file>
 
-<file path=ppt/slides/slide21.xml><?xml version="1.0" encoding="utf-8"?>
+<file path=ppt/slides/slide23.xml><?xml version="1.0" encoding="utf-8"?>
 <p:sld xmlns:a="http://schemas.openxmlformats.org/drawingml/2006/main" xmlns:r="http://schemas.openxmlformats.org/officeDocument/2006/relationships" xmlns:mc="http://schemas.openxmlformats.org/markup-compatibility/2006" xmlns:mv="urn:schemas-microsoft-com:mac:vml" xmlns:p="http://schemas.openxmlformats.org/presentationml/2006/main" xmlns:c="http://schemas.openxmlformats.org/drawingml/2006/chart" xmlns:dgm="http://schemas.openxmlformats.org/drawingml/2006/diagram" xmlns:o="urn:schemas-microsoft-com:office:office" xmlns:v="urn:schemas-microsoft-com:vml" xmlns:pvml="urn:schemas-microsoft-com:office:powerpoint" xmlns:com="http://schemas.openxmlformats.org/drawingml/2006/compatibility" xmlns:p14="http://schemas.microsoft.com/office/powerpoint/2010/main" xmlns:p15="http://schemas.microsoft.com/office/powerpoint/2012/main" xmlns:ahyp="http://schemas.microsoft.com/office/drawing/2018/hyperlinkcolor">
   <p:cSld>
     <p:spTree>
       <p:nvGrpSpPr>
-        <p:cNvPr id="416" name="Shape 416"/>
+        <p:cNvPr id="434" name="Shape 434"/>
         <p:cNvGrpSpPr/>
         <p:nvPr/>
       </p:nvGrpSpPr>
@@ -19617,7 +20530,7 @@
       </p:grpSpPr>
       <p:sp>
         <p:nvSpPr>
-          <p:cNvPr id="417" name="Google Shape;417;p33"/>
+          <p:cNvPr id="435" name="Google Shape;435;p35"/>
           <p:cNvSpPr txBox="1"/>
           <p:nvPr>
             <p:ph type="title"/>
@@ -19657,7 +20570,7 @@
       </p:sp>
       <p:sp>
         <p:nvSpPr>
-          <p:cNvPr id="418" name="Google Shape;418;p33"/>
+          <p:cNvPr id="436" name="Google Shape;436;p35"/>
           <p:cNvSpPr txBox="1"/>
           <p:nvPr>
             <p:ph idx="1" type="body"/>
@@ -19719,12 +20632,12 @@
 </p:sld>
 </file>
 
-<file path=ppt/slides/slide22.xml><?xml version="1.0" encoding="utf-8"?>
+<file path=ppt/slides/slide24.xml><?xml version="1.0" encoding="utf-8"?>
 <p:sld xmlns:a="http://schemas.openxmlformats.org/drawingml/2006/main" xmlns:r="http://schemas.openxmlformats.org/officeDocument/2006/relationships" xmlns:mc="http://schemas.openxmlformats.org/markup-compatibility/2006" xmlns:mv="urn:schemas-microsoft-com:mac:vml" xmlns:p="http://schemas.openxmlformats.org/presentationml/2006/main" xmlns:c="http://schemas.openxmlformats.org/drawingml/2006/chart" xmlns:dgm="http://schemas.openxmlformats.org/drawingml/2006/diagram" xmlns:o="urn:schemas-microsoft-com:office:office" xmlns:v="urn:schemas-microsoft-com:vml" xmlns:pvml="urn:schemas-microsoft-com:office:powerpoint" xmlns:com="http://schemas.openxmlformats.org/drawingml/2006/compatibility" xmlns:p14="http://schemas.microsoft.com/office/powerpoint/2010/main" xmlns:p15="http://schemas.microsoft.com/office/powerpoint/2012/main" xmlns:ahyp="http://schemas.microsoft.com/office/drawing/2018/hyperlinkcolor">
   <p:cSld>
     <p:spTree>
       <p:nvGrpSpPr>
-        <p:cNvPr id="422" name="Shape 422"/>
+        <p:cNvPr id="440" name="Shape 440"/>
         <p:cNvGrpSpPr/>
         <p:nvPr/>
       </p:nvGrpSpPr>
@@ -19738,7 +20651,7 @@
       </p:grpSpPr>
       <p:sp>
         <p:nvSpPr>
-          <p:cNvPr id="423" name="Google Shape;423;p34"/>
+          <p:cNvPr id="441" name="Google Shape;441;p36"/>
           <p:cNvSpPr txBox="1"/>
           <p:nvPr>
             <p:ph type="title"/>
@@ -19778,7 +20691,7 @@
       </p:sp>
       <p:sp>
         <p:nvSpPr>
-          <p:cNvPr id="424" name="Google Shape;424;p34"/>
+          <p:cNvPr id="442" name="Google Shape;442;p36"/>
           <p:cNvSpPr txBox="1"/>
           <p:nvPr>
             <p:ph idx="1" type="body"/>
@@ -19834,7 +20747,7 @@
       </p:sp>
       <p:sp>
         <p:nvSpPr>
-          <p:cNvPr id="425" name="Google Shape;425;p34"/>
+          <p:cNvPr id="443" name="Google Shape;443;p36"/>
           <p:cNvSpPr txBox="1"/>
           <p:nvPr/>
         </p:nvSpPr>
@@ -19905,7 +20818,7 @@
       </p:sp>
       <p:pic>
         <p:nvPicPr>
-          <p:cNvPr id="426" name="Google Shape;426;p34"/>
+          <p:cNvPr id="444" name="Google Shape;444;p36"/>
           <p:cNvPicPr preferRelativeResize="0"/>
           <p:nvPr/>
         </p:nvPicPr>
@@ -19939,12 +20852,12 @@
 </p:sld>
 </file>
 
-<file path=ppt/slides/slide23.xml><?xml version="1.0" encoding="utf-8"?>
+<file path=ppt/slides/slide25.xml><?xml version="1.0" encoding="utf-8"?>
 <p:sld xmlns:a="http://schemas.openxmlformats.org/drawingml/2006/main" xmlns:r="http://schemas.openxmlformats.org/officeDocument/2006/relationships" xmlns:mc="http://schemas.openxmlformats.org/markup-compatibility/2006" xmlns:mv="urn:schemas-microsoft-com:mac:vml" xmlns:p="http://schemas.openxmlformats.org/presentationml/2006/main" xmlns:c="http://schemas.openxmlformats.org/drawingml/2006/chart" xmlns:dgm="http://schemas.openxmlformats.org/drawingml/2006/diagram" xmlns:o="urn:schemas-microsoft-com:office:office" xmlns:v="urn:schemas-microsoft-com:vml" xmlns:pvml="urn:schemas-microsoft-com:office:powerpoint" xmlns:com="http://schemas.openxmlformats.org/drawingml/2006/compatibility" xmlns:p14="http://schemas.microsoft.com/office/powerpoint/2010/main" xmlns:p15="http://schemas.microsoft.com/office/powerpoint/2012/main" xmlns:ahyp="http://schemas.microsoft.com/office/drawing/2018/hyperlinkcolor">
   <p:cSld>
     <p:spTree>
       <p:nvGrpSpPr>
-        <p:cNvPr id="430" name="Shape 430"/>
+        <p:cNvPr id="448" name="Shape 448"/>
         <p:cNvGrpSpPr/>
         <p:nvPr/>
       </p:nvGrpSpPr>
@@ -19958,7 +20871,337 @@
       </p:grpSpPr>
       <p:sp>
         <p:nvSpPr>
-          <p:cNvPr id="431" name="Google Shape;431;p35"/>
+          <p:cNvPr id="449" name="Google Shape;449;p37"/>
+          <p:cNvSpPr txBox="1"/>
+          <p:nvPr>
+            <p:ph type="title"/>
+          </p:nvPr>
+        </p:nvSpPr>
+        <p:spPr>
+          <a:xfrm>
+            <a:off x="1303800" y="598575"/>
+            <a:ext cx="3923700" cy="1590000"/>
+          </a:xfrm>
+          <a:prstGeom prst="rect">
+            <a:avLst/>
+          </a:prstGeom>
+        </p:spPr>
+        <p:txBody>
+          <a:bodyPr anchorCtr="0" anchor="t" bIns="91425" lIns="91425" spcFirstLastPara="1" rIns="91425" wrap="square" tIns="91425">
+            <a:normAutofit/>
+          </a:bodyPr>
+          <a:lstStyle/>
+          <a:p>
+            <a:pPr indent="0" lvl="0" marL="0" rtl="0" algn="l">
+              <a:spcBef>
+                <a:spcPts val="0"/>
+              </a:spcBef>
+              <a:spcAft>
+                <a:spcPts val="0"/>
+              </a:spcAft>
+              <a:buNone/>
+            </a:pPr>
+            <a:r>
+              <a:rPr lang="en"/>
+              <a:t>Falsa correlaç</a:t>
+            </a:r>
+            <a:r>
+              <a:rPr lang="en"/>
+              <a:t>ão</a:t>
+            </a:r>
+            <a:endParaRPr/>
+          </a:p>
+        </p:txBody>
+      </p:sp>
+      <p:sp>
+        <p:nvSpPr>
+          <p:cNvPr id="450" name="Google Shape;450;p37"/>
+          <p:cNvSpPr txBox="1"/>
+          <p:nvPr>
+            <p:ph idx="1" type="body"/>
+          </p:nvPr>
+        </p:nvSpPr>
+        <p:spPr>
+          <a:xfrm>
+            <a:off x="1303800" y="1679500"/>
+            <a:ext cx="3312000" cy="2852100"/>
+          </a:xfrm>
+          <a:prstGeom prst="rect">
+            <a:avLst/>
+          </a:prstGeom>
+        </p:spPr>
+        <p:txBody>
+          <a:bodyPr anchorCtr="0" anchor="t" bIns="91425" lIns="91425" spcFirstLastPara="1" rIns="91425" wrap="square" tIns="91425">
+            <a:normAutofit lnSpcReduction="20000"/>
+          </a:bodyPr>
+          <a:lstStyle/>
+          <a:p>
+            <a:pPr indent="0" lvl="0" marL="0" rtl="0" algn="l">
+              <a:spcBef>
+                <a:spcPts val="1200"/>
+              </a:spcBef>
+              <a:spcAft>
+                <a:spcPts val="0"/>
+              </a:spcAft>
+              <a:buNone/>
+            </a:pPr>
+            <a:r>
+              <a:rPr lang="en">
+                <a:solidFill>
+                  <a:srgbClr val="000000"/>
+                </a:solidFill>
+              </a:rPr>
+              <a:t>Ocorre quando variáveis sem vínculo direto apresentam padrões visuais idênticos.</a:t>
+            </a:r>
+            <a:endParaRPr>
+              <a:solidFill>
+                <a:srgbClr val="000000"/>
+              </a:solidFill>
+            </a:endParaRPr>
+          </a:p>
+          <a:p>
+            <a:pPr indent="0" lvl="0" marL="0" rtl="0" algn="l">
+              <a:spcBef>
+                <a:spcPts val="1200"/>
+              </a:spcBef>
+              <a:spcAft>
+                <a:spcPts val="0"/>
+              </a:spcAft>
+              <a:buNone/>
+            </a:pPr>
+            <a:r>
+              <a:rPr lang="en">
+                <a:solidFill>
+                  <a:srgbClr val="000000"/>
+                </a:solidFill>
+              </a:rPr>
+              <a:t>Geralmente é induzida por eixos duplos manipulados, sugerindo uma causalidade inexistente baseada em mera coincidência ou fatores ocultos.</a:t>
+            </a:r>
+            <a:endParaRPr>
+              <a:solidFill>
+                <a:srgbClr val="000000"/>
+              </a:solidFill>
+            </a:endParaRPr>
+          </a:p>
+          <a:p>
+            <a:pPr indent="0" lvl="0" marL="0" rtl="0" algn="l">
+              <a:spcBef>
+                <a:spcPts val="1200"/>
+              </a:spcBef>
+              <a:spcAft>
+                <a:spcPts val="1200"/>
+              </a:spcAft>
+              <a:buNone/>
+            </a:pPr>
+            <a:r>
+              <a:rPr b="1" lang="en">
+                <a:solidFill>
+                  <a:srgbClr val="000000"/>
+                </a:solidFill>
+              </a:rPr>
+              <a:t>Como evitar:</a:t>
+            </a:r>
+            <a:r>
+              <a:rPr lang="en">
+                <a:solidFill>
+                  <a:srgbClr val="000000"/>
+                </a:solidFill>
+              </a:rPr>
+              <a:t> Use gráficos de dispersão para validar relações e prefira separar os dados em gráficos individuais lado a lado. Lembre-se: correlação não implica causalidade.</a:t>
+            </a:r>
+            <a:endParaRPr sz="1500">
+              <a:solidFill>
+                <a:srgbClr val="000000"/>
+              </a:solidFill>
+            </a:endParaRPr>
+          </a:p>
+        </p:txBody>
+      </p:sp>
+      <p:sp>
+        <p:nvSpPr>
+          <p:cNvPr id="451" name="Google Shape;451;p37"/>
+          <p:cNvSpPr txBox="1"/>
+          <p:nvPr/>
+        </p:nvSpPr>
+        <p:spPr>
+          <a:xfrm>
+            <a:off x="4870575" y="3934600"/>
+            <a:ext cx="3674100" cy="900900"/>
+          </a:xfrm>
+          <a:prstGeom prst="rect">
+            <a:avLst/>
+          </a:prstGeom>
+          <a:noFill/>
+          <a:ln>
+            <a:noFill/>
+          </a:ln>
+        </p:spPr>
+        <p:txBody>
+          <a:bodyPr anchorCtr="0" anchor="t" bIns="91425" lIns="91425" spcFirstLastPara="1" rIns="91425" wrap="square" tIns="91425">
+            <a:noAutofit/>
+          </a:bodyPr>
+          <a:lstStyle/>
+          <a:p>
+            <a:pPr indent="0" lvl="0" marL="0" rtl="0" algn="l">
+              <a:spcBef>
+                <a:spcPts val="0"/>
+              </a:spcBef>
+              <a:spcAft>
+                <a:spcPts val="0"/>
+              </a:spcAft>
+              <a:buNone/>
+            </a:pPr>
+            <a:r>
+              <a:rPr lang="en" sz="1300">
+                <a:solidFill>
+                  <a:schemeClr val="dk2"/>
+                </a:solidFill>
+                <a:latin typeface="Nunito"/>
+                <a:ea typeface="Nunito"/>
+                <a:cs typeface="Nunito"/>
+                <a:sym typeface="Nunito"/>
+              </a:rPr>
+              <a:t>Fonte: </a:t>
+            </a:r>
+            <a:r>
+              <a:rPr lang="en" sz="1300" u="sng">
+                <a:solidFill>
+                  <a:schemeClr val="hlink"/>
+                </a:solidFill>
+                <a:latin typeface="Nunito"/>
+                <a:ea typeface="Nunito"/>
+                <a:cs typeface="Nunito"/>
+                <a:sym typeface="Nunito"/>
+                <a:hlinkClick r:id="rId3"/>
+              </a:rPr>
+              <a:t>https://www.tylervigen.com/spurious/correlation/2638_yogurt-consumption_correlates-with_the-bank-of-nova-scotias-stock-price</a:t>
+            </a:r>
+            <a:endParaRPr sz="1300">
+              <a:solidFill>
+                <a:schemeClr val="dk2"/>
+              </a:solidFill>
+              <a:latin typeface="Nunito"/>
+              <a:ea typeface="Nunito"/>
+              <a:cs typeface="Nunito"/>
+              <a:sym typeface="Nunito"/>
+            </a:endParaRPr>
+          </a:p>
+        </p:txBody>
+      </p:sp>
+      <p:pic>
+        <p:nvPicPr>
+          <p:cNvPr id="452" name="Google Shape;452;p37"/>
+          <p:cNvPicPr preferRelativeResize="0"/>
+          <p:nvPr/>
+        </p:nvPicPr>
+        <p:blipFill>
+          <a:blip r:embed="rId4">
+            <a:alphaModFix/>
+          </a:blip>
+          <a:stretch>
+            <a:fillRect/>
+          </a:stretch>
+        </p:blipFill>
+        <p:spPr>
+          <a:xfrm>
+            <a:off x="4940550" y="1181100"/>
+            <a:ext cx="3611700" cy="2263332"/>
+          </a:xfrm>
+          <a:prstGeom prst="rect">
+            <a:avLst/>
+          </a:prstGeom>
+          <a:noFill/>
+          <a:ln>
+            <a:noFill/>
+          </a:ln>
+        </p:spPr>
+      </p:pic>
+      <p:sp>
+        <p:nvSpPr>
+          <p:cNvPr id="453" name="Google Shape;453;p37"/>
+          <p:cNvSpPr txBox="1"/>
+          <p:nvPr/>
+        </p:nvSpPr>
+        <p:spPr>
+          <a:xfrm>
+            <a:off x="4940550" y="3387000"/>
+            <a:ext cx="3576000" cy="510900"/>
+          </a:xfrm>
+          <a:prstGeom prst="rect">
+            <a:avLst/>
+          </a:prstGeom>
+          <a:noFill/>
+          <a:ln>
+            <a:noFill/>
+          </a:ln>
+        </p:spPr>
+        <p:txBody>
+          <a:bodyPr anchorCtr="0" anchor="t" bIns="91425" lIns="91425" spcFirstLastPara="1" rIns="91425" wrap="square" tIns="91425">
+            <a:noAutofit/>
+          </a:bodyPr>
+          <a:lstStyle/>
+          <a:p>
+            <a:pPr indent="0" lvl="0" marL="0" rtl="0" algn="l">
+              <a:spcBef>
+                <a:spcPts val="0"/>
+              </a:spcBef>
+              <a:spcAft>
+                <a:spcPts val="0"/>
+              </a:spcAft>
+              <a:buNone/>
+            </a:pPr>
+            <a:r>
+              <a:rPr lang="en" sz="1100">
+                <a:solidFill>
+                  <a:srgbClr val="666666"/>
+                </a:solidFill>
+                <a:latin typeface="Nunito"/>
+                <a:ea typeface="Nunito"/>
+                <a:cs typeface="Nunito"/>
+                <a:sym typeface="Nunito"/>
+              </a:rPr>
+              <a:t>Tradução: Consumo de iogurte per capita nos EUA x Preço da ação do Banco de Nova Escócia</a:t>
+            </a:r>
+            <a:endParaRPr sz="1100">
+              <a:solidFill>
+                <a:srgbClr val="666666"/>
+              </a:solidFill>
+              <a:latin typeface="Nunito"/>
+              <a:ea typeface="Nunito"/>
+              <a:cs typeface="Nunito"/>
+              <a:sym typeface="Nunito"/>
+            </a:endParaRPr>
+          </a:p>
+        </p:txBody>
+      </p:sp>
+    </p:spTree>
+  </p:cSld>
+  <p:clrMapOvr>
+    <a:masterClrMapping/>
+  </p:clrMapOvr>
+</p:sld>
+</file>
+
+<file path=ppt/slides/slide26.xml><?xml version="1.0" encoding="utf-8"?>
+<p:sld xmlns:a="http://schemas.openxmlformats.org/drawingml/2006/main" xmlns:r="http://schemas.openxmlformats.org/officeDocument/2006/relationships" xmlns:mc="http://schemas.openxmlformats.org/markup-compatibility/2006" xmlns:mv="urn:schemas-microsoft-com:mac:vml" xmlns:p="http://schemas.openxmlformats.org/presentationml/2006/main" xmlns:c="http://schemas.openxmlformats.org/drawingml/2006/chart" xmlns:dgm="http://schemas.openxmlformats.org/drawingml/2006/diagram" xmlns:o="urn:schemas-microsoft-com:office:office" xmlns:v="urn:schemas-microsoft-com:vml" xmlns:pvml="urn:schemas-microsoft-com:office:powerpoint" xmlns:com="http://schemas.openxmlformats.org/drawingml/2006/compatibility" xmlns:p14="http://schemas.microsoft.com/office/powerpoint/2010/main" xmlns:p15="http://schemas.microsoft.com/office/powerpoint/2012/main" xmlns:ahyp="http://schemas.microsoft.com/office/drawing/2018/hyperlinkcolor">
+  <p:cSld>
+    <p:spTree>
+      <p:nvGrpSpPr>
+        <p:cNvPr id="457" name="Shape 457"/>
+        <p:cNvGrpSpPr/>
+        <p:nvPr/>
+      </p:nvGrpSpPr>
+      <p:grpSpPr>
+        <a:xfrm>
+          <a:off x="0" y="0"/>
+          <a:ext cx="0" cy="0"/>
+          <a:chOff x="0" y="0"/>
+          <a:chExt cx="0" cy="0"/>
+        </a:xfrm>
+      </p:grpSpPr>
+      <p:sp>
+        <p:nvSpPr>
+          <p:cNvPr id="458" name="Google Shape;458;p38"/>
           <p:cNvSpPr txBox="1"/>
           <p:nvPr>
             <p:ph type="title"/>
@@ -19998,7 +21241,7 @@
       </p:sp>
       <p:sp>
         <p:nvSpPr>
-          <p:cNvPr id="432" name="Google Shape;432;p35"/>
+          <p:cNvPr id="459" name="Google Shape;459;p38"/>
           <p:cNvSpPr txBox="1"/>
           <p:nvPr>
             <p:ph idx="1" type="body"/>
@@ -20054,7 +21297,7 @@
       </p:sp>
       <p:sp>
         <p:nvSpPr>
-          <p:cNvPr id="433" name="Google Shape;433;p35"/>
+          <p:cNvPr id="460" name="Google Shape;460;p38"/>
           <p:cNvSpPr txBox="1"/>
           <p:nvPr/>
         </p:nvSpPr>
@@ -20125,7 +21368,7 @@
       </p:sp>
       <p:pic>
         <p:nvPicPr>
-          <p:cNvPr id="434" name="Google Shape;434;p35"/>
+          <p:cNvPr id="461" name="Google Shape;461;p38"/>
           <p:cNvPicPr preferRelativeResize="0"/>
           <p:nvPr/>
         </p:nvPicPr>
@@ -20159,12 +21402,12 @@
 </p:sld>
 </file>
 
-<file path=ppt/slides/slide24.xml><?xml version="1.0" encoding="utf-8"?>
+<file path=ppt/slides/slide27.xml><?xml version="1.0" encoding="utf-8"?>
 <p:sld xmlns:a="http://schemas.openxmlformats.org/drawingml/2006/main" xmlns:r="http://schemas.openxmlformats.org/officeDocument/2006/relationships" xmlns:mc="http://schemas.openxmlformats.org/markup-compatibility/2006" xmlns:mv="urn:schemas-microsoft-com:mac:vml" xmlns:p="http://schemas.openxmlformats.org/presentationml/2006/main" xmlns:c="http://schemas.openxmlformats.org/drawingml/2006/chart" xmlns:dgm="http://schemas.openxmlformats.org/drawingml/2006/diagram" xmlns:o="urn:schemas-microsoft-com:office:office" xmlns:v="urn:schemas-microsoft-com:vml" xmlns:pvml="urn:schemas-microsoft-com:office:powerpoint" xmlns:com="http://schemas.openxmlformats.org/drawingml/2006/compatibility" xmlns:p14="http://schemas.microsoft.com/office/powerpoint/2010/main" xmlns:p15="http://schemas.microsoft.com/office/powerpoint/2012/main" xmlns:ahyp="http://schemas.microsoft.com/office/drawing/2018/hyperlinkcolor">
   <p:cSld>
     <p:spTree>
       <p:nvGrpSpPr>
-        <p:cNvPr id="438" name="Shape 438"/>
+        <p:cNvPr id="465" name="Shape 465"/>
         <p:cNvGrpSpPr/>
         <p:nvPr/>
       </p:nvGrpSpPr>
@@ -20178,7 +21421,7 @@
       </p:grpSpPr>
       <p:sp>
         <p:nvSpPr>
-          <p:cNvPr id="439" name="Google Shape;439;p36"/>
+          <p:cNvPr id="466" name="Google Shape;466;p39"/>
           <p:cNvSpPr txBox="1"/>
           <p:nvPr>
             <p:ph type="title"/>

</xml_diff>